<commit_message>
adição de link de video ao ppt
</commit_message>
<xml_diff>
--- a/MindMove.pptx
+++ b/MindMove.pptx
@@ -148,7 +148,7 @@
 <file path=ppt/revisionInfo.xml><?xml version="1.0" encoding="utf-8"?>
 <p1510:revInfo xmlns:a="http://schemas.openxmlformats.org/drawingml/2006/main" xmlns:r="http://schemas.openxmlformats.org/officeDocument/2006/relationships" xmlns:p1510="http://schemas.microsoft.com/office/powerpoint/2015/10/main">
   <p1510:revLst>
-    <p1510:client id="{0098CBE5-14F3-4F79-B2D5-566AE0C8256B}" v="8" dt="2026-05-14T07:52:27.162"/>
+    <p1510:client id="{0098CBE5-14F3-4F79-B2D5-566AE0C8256B}" v="12" dt="2026-05-14T08:15:32.139"/>
   </p1510:revLst>
 </p1510:revInfo>
 </file>
@@ -508,8 +508,8 @@
   </pc:docChgLst>
   <pc:docChgLst>
     <pc:chgData name="Gabriela Gonçalves Carneiro" userId="d552a4f0-38ab-4544-a7a4-6025654d07bb" providerId="ADAL" clId="{D03F746D-BE5D-4789-93E6-42C6E52F57A2}"/>
-    <pc:docChg chg="addSld delSld modSld">
-      <pc:chgData name="Gabriela Gonçalves Carneiro" userId="d552a4f0-38ab-4544-a7a4-6025654d07bb" providerId="ADAL" clId="{D03F746D-BE5D-4789-93E6-42C6E52F57A2}" dt="2026-05-14T07:52:27.162" v="228"/>
+    <pc:docChg chg="undo custSel addSld delSld modSld">
+      <pc:chgData name="Gabriela Gonçalves Carneiro" userId="d552a4f0-38ab-4544-a7a4-6025654d07bb" providerId="ADAL" clId="{D03F746D-BE5D-4789-93E6-42C6E52F57A2}" dt="2026-05-14T08:17:00.147" v="283" actId="20577"/>
       <pc:docMkLst>
         <pc:docMk/>
       </pc:docMkLst>
@@ -550,14 +550,14 @@
           <pc:sldMk cId="472268791" sldId="269"/>
         </pc:sldMkLst>
       </pc:sldChg>
-      <pc:sldChg chg="modSp add mod">
-        <pc:chgData name="Gabriela Gonçalves Carneiro" userId="d552a4f0-38ab-4544-a7a4-6025654d07bb" providerId="ADAL" clId="{D03F746D-BE5D-4789-93E6-42C6E52F57A2}" dt="2026-05-14T07:51:20.224" v="225"/>
+      <pc:sldChg chg="addSp delSp modSp add mod">
+        <pc:chgData name="Gabriela Gonçalves Carneiro" userId="d552a4f0-38ab-4544-a7a4-6025654d07bb" providerId="ADAL" clId="{D03F746D-BE5D-4789-93E6-42C6E52F57A2}" dt="2026-05-14T08:17:00.147" v="283" actId="20577"/>
         <pc:sldMkLst>
           <pc:docMk/>
           <pc:sldMk cId="573965222" sldId="269"/>
         </pc:sldMkLst>
         <pc:spChg chg="mod">
-          <ac:chgData name="Gabriela Gonçalves Carneiro" userId="d552a4f0-38ab-4544-a7a4-6025654d07bb" providerId="ADAL" clId="{D03F746D-BE5D-4789-93E6-42C6E52F57A2}" dt="2026-05-14T07:49:31.633" v="108" actId="20577"/>
+          <ac:chgData name="Gabriela Gonçalves Carneiro" userId="d552a4f0-38ab-4544-a7a4-6025654d07bb" providerId="ADAL" clId="{D03F746D-BE5D-4789-93E6-42C6E52F57A2}" dt="2026-05-14T08:17:00.147" v="283" actId="20577"/>
           <ac:spMkLst>
             <pc:docMk/>
             <pc:sldMk cId="573965222" sldId="269"/>
@@ -565,13 +565,45 @@
           </ac:spMkLst>
         </pc:spChg>
         <pc:spChg chg="mod">
-          <ac:chgData name="Gabriela Gonçalves Carneiro" userId="d552a4f0-38ab-4544-a7a4-6025654d07bb" providerId="ADAL" clId="{D03F746D-BE5D-4789-93E6-42C6E52F57A2}" dt="2026-05-14T07:51:20.224" v="225"/>
+          <ac:chgData name="Gabriela Gonçalves Carneiro" userId="d552a4f0-38ab-4544-a7a4-6025654d07bb" providerId="ADAL" clId="{D03F746D-BE5D-4789-93E6-42C6E52F57A2}" dt="2026-05-14T08:14:19.990" v="273" actId="1076"/>
           <ac:spMkLst>
             <pc:docMk/>
             <pc:sldMk cId="573965222" sldId="269"/>
             <ac:spMk id="15" creationId="{A0308FB3-1071-6A7F-9B36-628632EFD52E}"/>
           </ac:spMkLst>
         </pc:spChg>
+        <pc:spChg chg="add del">
+          <ac:chgData name="Gabriela Gonçalves Carneiro" userId="d552a4f0-38ab-4544-a7a4-6025654d07bb" providerId="ADAL" clId="{D03F746D-BE5D-4789-93E6-42C6E52F57A2}" dt="2026-05-14T08:13:08.620" v="232" actId="22"/>
+          <ac:spMkLst>
+            <pc:docMk/>
+            <pc:sldMk cId="573965222" sldId="269"/>
+            <ac:spMk id="17" creationId="{1B06E7F4-4E57-67FC-24EC-5B431D18BC6B}"/>
+          </ac:spMkLst>
+        </pc:spChg>
+        <pc:spChg chg="add mod">
+          <ac:chgData name="Gabriela Gonçalves Carneiro" userId="d552a4f0-38ab-4544-a7a4-6025654d07bb" providerId="ADAL" clId="{D03F746D-BE5D-4789-93E6-42C6E52F57A2}" dt="2026-05-14T08:14:13.954" v="272" actId="1076"/>
+          <ac:spMkLst>
+            <pc:docMk/>
+            <pc:sldMk cId="573965222" sldId="269"/>
+            <ac:spMk id="18" creationId="{DC3D3241-746D-30FC-DCE5-9C5F521652F0}"/>
+          </ac:spMkLst>
+        </pc:spChg>
+        <pc:spChg chg="add mod">
+          <ac:chgData name="Gabriela Gonçalves Carneiro" userId="d552a4f0-38ab-4544-a7a4-6025654d07bb" providerId="ADAL" clId="{D03F746D-BE5D-4789-93E6-42C6E52F57A2}" dt="2026-05-14T08:15:03.552" v="281"/>
+          <ac:spMkLst>
+            <pc:docMk/>
+            <pc:sldMk cId="573965222" sldId="269"/>
+            <ac:spMk id="19" creationId="{77FC34A0-2CF6-32F8-B21B-DEFF1C72DD61}"/>
+          </ac:spMkLst>
+        </pc:spChg>
+        <pc:grpChg chg="mod">
+          <ac:chgData name="Gabriela Gonçalves Carneiro" userId="d552a4f0-38ab-4544-a7a4-6025654d07bb" providerId="ADAL" clId="{D03F746D-BE5D-4789-93E6-42C6E52F57A2}" dt="2026-05-14T08:13:48.451" v="271" actId="1076"/>
+          <ac:grpSpMkLst>
+            <pc:docMk/>
+            <pc:sldMk cId="573965222" sldId="269"/>
+            <ac:grpSpMk id="11" creationId="{1A36D9CF-907C-AF5F-9901-36BC33CBC0FB}"/>
+          </ac:grpSpMkLst>
+        </pc:grpChg>
       </pc:sldChg>
       <pc:sldChg chg="del">
         <pc:chgData name="Gabriela Gonçalves Carneiro" userId="d552a4f0-38ab-4544-a7a4-6025654d07bb" providerId="ADAL" clId="{D03F746D-BE5D-4789-93E6-42C6E52F57A2}" dt="2026-05-14T07:46:56.050" v="2" actId="47"/>
@@ -6630,8 +6662,8 @@
         </p:nvSpPr>
         <p:spPr>
           <a:xfrm>
-            <a:off x="2281335" y="2789450"/>
-            <a:ext cx="13773557" cy="2194190"/>
+            <a:off x="2460753" y="4996249"/>
+            <a:ext cx="13773557" cy="2071336"/>
           </a:xfrm>
           <a:prstGeom prst="rect">
             <a:avLst/>
@@ -6649,7 +6681,7 @@
               </a:lnSpc>
             </a:pPr>
             <a:r>
-              <a:rPr lang="en-US" sz="9129" dirty="0">
+              <a:rPr lang="en-US" sz="5500" dirty="0">
                 <a:solidFill>
                   <a:srgbClr val="000000"/>
                 </a:solidFill>
@@ -6661,7 +6693,55 @@
               <a:t>Link do </a:t>
             </a:r>
             <a:r>
-              <a:rPr lang="en-US" sz="9129" dirty="0" err="1">
+              <a:rPr lang="en-US" sz="5500">
+                <a:solidFill>
+                  <a:srgbClr val="000000"/>
+                </a:solidFill>
+                <a:latin typeface="Calibri (MS)"/>
+                <a:ea typeface="Calibri (MS)"/>
+                <a:cs typeface="Calibri (MS)"/>
+                <a:sym typeface="Calibri (MS)"/>
+              </a:rPr>
+              <a:t>vídeo</a:t>
+            </a:r>
+            <a:r>
+              <a:rPr lang="en-US" sz="5500" dirty="0">
+                <a:solidFill>
+                  <a:srgbClr val="000000"/>
+                </a:solidFill>
+                <a:latin typeface="Calibri (MS)"/>
+                <a:ea typeface="Calibri (MS)"/>
+                <a:cs typeface="Calibri (MS)"/>
+                <a:sym typeface="Calibri (MS)"/>
+              </a:rPr>
+              <a:t> </a:t>
+            </a:r>
+            <a:r>
+              <a:rPr lang="en-US" sz="5500" dirty="0" err="1">
+                <a:solidFill>
+                  <a:srgbClr val="000000"/>
+                </a:solidFill>
+                <a:latin typeface="Calibri (MS)"/>
+                <a:ea typeface="Calibri (MS)"/>
+                <a:cs typeface="Calibri (MS)"/>
+                <a:sym typeface="Calibri (MS)"/>
+              </a:rPr>
+              <a:t>demonstrativo</a:t>
+            </a:r>
+            <a:r>
+              <a:rPr lang="en-US" sz="5500" dirty="0">
+                <a:solidFill>
+                  <a:srgbClr val="000000"/>
+                </a:solidFill>
+                <a:latin typeface="Calibri (MS)"/>
+                <a:ea typeface="Calibri (MS)"/>
+                <a:cs typeface="Calibri (MS)"/>
+                <a:sym typeface="Calibri (MS)"/>
+              </a:rPr>
+              <a:t> do </a:t>
+            </a:r>
+            <a:r>
+              <a:rPr lang="en-US" sz="5500" dirty="0" err="1">
                 <a:solidFill>
                   <a:srgbClr val="000000"/>
                 </a:solidFill>
@@ -6673,7 +6753,7 @@
               <a:t>protótipo</a:t>
             </a:r>
             <a:r>
-              <a:rPr lang="en-US" sz="9129" dirty="0">
+              <a:rPr lang="en-US" sz="5500" dirty="0">
                 <a:solidFill>
                   <a:srgbClr val="000000"/>
                 </a:solidFill>
@@ -6685,7 +6765,7 @@
               <a:t> da App </a:t>
             </a:r>
             <a:r>
-              <a:rPr lang="en-US" sz="9129" dirty="0" err="1">
+              <a:rPr lang="en-US" sz="5500" dirty="0" err="1">
                 <a:solidFill>
                   <a:srgbClr val="000000"/>
                 </a:solidFill>
@@ -6696,7 +6776,7 @@
               </a:rPr>
               <a:t>MindMove</a:t>
             </a:r>
-            <a:endParaRPr lang="en-US" sz="9129" dirty="0">
+            <a:endParaRPr lang="en-US" sz="5500" dirty="0">
               <a:solidFill>
                 <a:srgbClr val="000000"/>
               </a:solidFill>
@@ -6722,7 +6802,7 @@
         </p:nvSpPr>
         <p:spPr>
           <a:xfrm>
-            <a:off x="2219052" y="5143500"/>
+            <a:off x="2133600" y="3322468"/>
             <a:ext cx="13773557" cy="1225848"/>
           </a:xfrm>
           <a:prstGeom prst="rect">
@@ -6745,6 +6825,140 @@
                 <a:hlinkClick r:id="rId4"/>
               </a:rPr>
               <a:t>https://www.figma.com/make/jqpvN3R267yLQH77eYXytl/Criar-tela-inicial-MindMove?code-node-id=0-9&amp;fullscreen=1</a:t>
+            </a:r>
+            <a:endParaRPr lang="pt-PT" sz="2800" dirty="0"/>
+          </a:p>
+        </p:txBody>
+      </p:sp>
+      <p:sp>
+        <p:nvSpPr>
+          <p:cNvPr id="18" name="TextBox 14">
+            <a:extLst>
+              <a:ext uri="{FF2B5EF4-FFF2-40B4-BE49-F238E27FC236}">
+                <a16:creationId xmlns:a16="http://schemas.microsoft.com/office/drawing/2014/main" id="{DC3D3241-746D-30FC-DCE5-9C5F521652F0}"/>
+              </a:ext>
+            </a:extLst>
+          </p:cNvPr>
+          <p:cNvSpPr txBox="1"/>
+          <p:nvPr/>
+        </p:nvSpPr>
+        <p:spPr>
+          <a:xfrm>
+            <a:off x="2433734" y="2136571"/>
+            <a:ext cx="13773557" cy="994118"/>
+          </a:xfrm>
+          <a:prstGeom prst="rect">
+            <a:avLst/>
+          </a:prstGeom>
+        </p:spPr>
+        <p:txBody>
+          <a:bodyPr lIns="0" tIns="0" rIns="0" bIns="0" rtlCol="0" anchor="t">
+            <a:spAutoFit/>
+          </a:bodyPr>
+          <a:lstStyle/>
+          <a:p>
+            <a:pPr lvl="0" algn="ctr">
+              <a:lnSpc>
+                <a:spcPts val="8398"/>
+              </a:lnSpc>
+            </a:pPr>
+            <a:r>
+              <a:rPr lang="en-US" sz="5500" dirty="0">
+                <a:solidFill>
+                  <a:srgbClr val="000000"/>
+                </a:solidFill>
+                <a:latin typeface="Calibri (MS)"/>
+                <a:ea typeface="Calibri (MS)"/>
+                <a:cs typeface="Calibri (MS)"/>
+                <a:sym typeface="Calibri (MS)"/>
+              </a:rPr>
+              <a:t>Link do </a:t>
+            </a:r>
+            <a:r>
+              <a:rPr lang="en-US" sz="5500" dirty="0" err="1">
+                <a:solidFill>
+                  <a:srgbClr val="000000"/>
+                </a:solidFill>
+                <a:latin typeface="Calibri (MS)"/>
+                <a:ea typeface="Calibri (MS)"/>
+                <a:cs typeface="Calibri (MS)"/>
+                <a:sym typeface="Calibri (MS)"/>
+              </a:rPr>
+              <a:t>protótipo</a:t>
+            </a:r>
+            <a:r>
+              <a:rPr lang="en-US" sz="5500" dirty="0">
+                <a:solidFill>
+                  <a:srgbClr val="000000"/>
+                </a:solidFill>
+                <a:latin typeface="Calibri (MS)"/>
+                <a:ea typeface="Calibri (MS)"/>
+                <a:cs typeface="Calibri (MS)"/>
+                <a:sym typeface="Calibri (MS)"/>
+              </a:rPr>
+              <a:t> da App </a:t>
+            </a:r>
+            <a:r>
+              <a:rPr lang="en-US" sz="5500" dirty="0" err="1">
+                <a:solidFill>
+                  <a:srgbClr val="000000"/>
+                </a:solidFill>
+                <a:latin typeface="Calibri (MS)"/>
+                <a:ea typeface="Calibri (MS)"/>
+                <a:cs typeface="Calibri (MS)"/>
+                <a:sym typeface="Calibri (MS)"/>
+              </a:rPr>
+              <a:t>MindMove</a:t>
+            </a:r>
+            <a:endParaRPr lang="en-US" sz="5500" dirty="0">
+              <a:solidFill>
+                <a:srgbClr val="000000"/>
+              </a:solidFill>
+              <a:latin typeface="Calibri (MS)"/>
+              <a:ea typeface="Calibri (MS)"/>
+              <a:cs typeface="Calibri (MS)"/>
+              <a:sym typeface="Calibri (MS)"/>
+            </a:endParaRPr>
+          </a:p>
+        </p:txBody>
+      </p:sp>
+      <p:sp>
+        <p:nvSpPr>
+          <p:cNvPr id="19" name="TextBox 15">
+            <a:extLst>
+              <a:ext uri="{FF2B5EF4-FFF2-40B4-BE49-F238E27FC236}">
+                <a16:creationId xmlns:a16="http://schemas.microsoft.com/office/drawing/2014/main" id="{77FC34A0-2CF6-32F8-B21B-DEFF1C72DD61}"/>
+              </a:ext>
+            </a:extLst>
+          </p:cNvPr>
+          <p:cNvSpPr txBox="1"/>
+          <p:nvPr/>
+        </p:nvSpPr>
+        <p:spPr>
+          <a:xfrm>
+            <a:off x="2036717" y="7223119"/>
+            <a:ext cx="13773557" cy="579518"/>
+          </a:xfrm>
+          <a:prstGeom prst="rect">
+            <a:avLst/>
+          </a:prstGeom>
+        </p:spPr>
+        <p:txBody>
+          <a:bodyPr lIns="0" tIns="0" rIns="0" bIns="0" rtlCol="0" anchor="t">
+            <a:spAutoFit/>
+          </a:bodyPr>
+          <a:lstStyle/>
+          <a:p>
+            <a:pPr>
+              <a:lnSpc>
+                <a:spcPct val="150000"/>
+              </a:lnSpc>
+            </a:pPr>
+            <a:r>
+              <a:rPr lang="pt-PT" sz="2800" dirty="0">
+                <a:hlinkClick r:id="rId5"/>
+              </a:rPr>
+              <a:t>https://www.youtube.com/watch?v=cAeMl6o3SJE</a:t>
             </a:r>
             <a:endParaRPr lang="pt-PT" sz="2800" dirty="0"/>
           </a:p>

</xml_diff>